<commit_message>
Put the OIDC subject claim on slide 1
"There are no secrets" is the strongest single claim in this demo, and the
slide only gestured at it with "OIDC -> Britive". Now it shows the actual
credential:

    sub = repo:ClintPollock/britive-jit-demo:ref:refs/heads/main

That string, bound to a Britive federated service identity, is the whole
thing. Change the owner, the repo or the branch and it stops matching.
There is nothing in the repository to steal.

Also corrects the flow box, which still said "07:00 daily" after the
schedule moved to weekdays.

Co-Authored-By: Claude Opus 5 (1M context) <noreply@anthropic.com>
</commit_message>
<xml_diff>
--- a/slides/britive-agentic-jit.pptx
+++ b/slides/britive-agentic-jit.pptx
@@ -3152,8 +3152,8 @@
         </p:nvSpPr>
         <p:spPr>
           <a:xfrm>
-            <a:off x="640080" y="1417320"/>
-            <a:ext cx="3200400" cy="1371600"/>
+            <a:off x="640080" y="1325880"/>
+            <a:ext cx="3200400" cy="1325880"/>
           </a:xfrm>
           <a:prstGeom prst="roundRect">
             <a:avLst>
@@ -3198,8 +3198,8 @@
         </p:nvSpPr>
         <p:spPr>
           <a:xfrm>
-            <a:off x="841247" y="1600200"/>
-            <a:ext cx="2798064" cy="1005840"/>
+            <a:off x="841247" y="1508760"/>
+            <a:ext cx="2798064" cy="960119"/>
           </a:xfrm>
           <a:prstGeom prst="rect">
             <a:avLst/>
@@ -3240,7 +3240,7 @@
                 </a:solidFill>
                 <a:latin typeface="Segoe UI"/>
               </a:rPr>
-              <a:t>Machine identity, 07:00 daily</a:t>
+              <a:t>Machine identity, 07:00 Mon–Fri</a:t>
             </a:r>
           </a:p>
           <a:p>
@@ -3272,7 +3272,7 @@
                 </a:solidFill>
                 <a:latin typeface="Segoe UI"/>
               </a:rPr>
-              <a:t>No secrets in the repo</a:t>
+              <a:t>Nothing stored in the repo</a:t>
             </a:r>
           </a:p>
         </p:txBody>
@@ -3285,7 +3285,7 @@
         </p:nvSpPr>
         <p:spPr>
           <a:xfrm>
-            <a:off x="3977639" y="2002536"/>
+            <a:off x="3977639" y="1883664"/>
             <a:ext cx="685800" cy="201168"/>
           </a:xfrm>
           <a:prstGeom prst="rightArrow">
@@ -3329,8 +3329,8 @@
         </p:nvSpPr>
         <p:spPr>
           <a:xfrm>
-            <a:off x="4800600" y="1417320"/>
-            <a:ext cx="2743200" cy="1371600"/>
+            <a:off x="4800600" y="1325880"/>
+            <a:ext cx="2743200" cy="1325880"/>
           </a:xfrm>
           <a:prstGeom prst="roundRect">
             <a:avLst>
@@ -3375,8 +3375,8 @@
         </p:nvSpPr>
         <p:spPr>
           <a:xfrm>
-            <a:off x="5001768" y="1600200"/>
-            <a:ext cx="2340864" cy="1005840"/>
+            <a:off x="5001768" y="1508760"/>
+            <a:ext cx="2340864" cy="960119"/>
           </a:xfrm>
           <a:prstGeom prst="rect">
             <a:avLst/>
@@ -3478,7 +3478,7 @@
         </p:nvSpPr>
         <p:spPr>
           <a:xfrm>
-            <a:off x="7726679" y="2002536"/>
+            <a:off x="7726679" y="1883664"/>
             <a:ext cx="685800" cy="201168"/>
           </a:xfrm>
           <a:prstGeom prst="rightArrow">
@@ -3522,8 +3522,8 @@
         </p:nvSpPr>
         <p:spPr>
           <a:xfrm>
-            <a:off x="8732520" y="1417320"/>
-            <a:ext cx="2834640" cy="1371600"/>
+            <a:off x="8732520" y="1325880"/>
+            <a:ext cx="2834640" cy="1325880"/>
           </a:xfrm>
           <a:prstGeom prst="roundRect">
             <a:avLst>
@@ -3568,8 +3568,8 @@
         </p:nvSpPr>
         <p:spPr>
           <a:xfrm>
-            <a:off x="8933688" y="1600200"/>
-            <a:ext cx="2432304" cy="1005840"/>
+            <a:off x="8933688" y="1508760"/>
+            <a:ext cx="2432304" cy="960119"/>
           </a:xfrm>
           <a:prstGeom prst="rect">
             <a:avLst/>
@@ -3649,14 +3649,60 @@
       </p:sp>
       <p:sp>
         <p:nvSpPr>
-          <p:cNvPr id="11" name="TextBox 10"/>
+          <p:cNvPr id="11" name="Rounded Rectangle 10"/>
+          <p:cNvSpPr/>
+          <p:nvPr/>
+        </p:nvSpPr>
+        <p:spPr>
+          <a:xfrm>
+            <a:off x="640080" y="2761488"/>
+            <a:ext cx="10927080" cy="566928"/>
+          </a:xfrm>
+          <a:prstGeom prst="roundRect">
+            <a:avLst>
+              <a:gd name="adj" fmla="val 6000"/>
+            </a:avLst>
+          </a:prstGeom>
+          <a:solidFill>
+            <a:srgbClr val="ECE7F7"/>
+          </a:solidFill>
+          <a:ln w="12700">
+            <a:solidFill>
+              <a:srgbClr val="D2C7EA"/>
+            </a:solidFill>
+          </a:ln>
+          <a:effectLst/>
+        </p:spPr>
+        <p:style>
+          <a:lnRef idx="1">
+            <a:schemeClr val="accent1"/>
+          </a:lnRef>
+          <a:fillRef idx="3">
+            <a:schemeClr val="accent1"/>
+          </a:fillRef>
+          <a:effectRef idx="2">
+            <a:schemeClr val="accent1"/>
+          </a:effectRef>
+          <a:fontRef idx="minor">
+            <a:schemeClr val="lt1"/>
+          </a:fontRef>
+        </p:style>
+        <p:txBody>
+          <a:bodyPr rtlCol="0" anchor="ctr"/>
+          <a:lstStyle/>
+          <a:p/>
+        </p:txBody>
+      </p:sp>
+      <p:sp>
+        <p:nvSpPr>
+          <p:cNvPr id="12" name="TextBox 11"/>
           <p:cNvSpPr txBox="1"/>
           <p:nvPr/>
         </p:nvSpPr>
         <p:spPr>
           <a:xfrm>
-            <a:off x="640080" y="3017520"/>
-            <a:ext cx="10972800" cy="274320"/>
+            <a:off x="960120" y="2761488"/>
+            <a:ext cx="10332720" cy="566928"/>
           </a:xfrm>
           <a:prstGeom prst="rect">
             <a:avLst/>
@@ -3664,10 +3710,26 @@
           <a:noFill/>
         </p:spPr>
         <p:txBody>
-          <a:bodyPr wrap="square" anchor="t" lIns="0" rIns="0" tIns="0" bIns="0">
+          <a:bodyPr wrap="square" anchor="ctr" lIns="0" rIns="0" tIns="0" bIns="0">
             <a:spAutoFit/>
           </a:bodyPr>
           <a:lstStyle/>
+          <a:p>
+            <a:pPr algn="l">
+              <a:spcAft>
+                <a:spcPts val="300"/>
+              </a:spcAft>
+            </a:pPr>
+            <a:r>
+              <a:rPr sz="950" b="1">
+                <a:solidFill>
+                  <a:srgbClr val="6C4BB6"/>
+                </a:solidFill>
+                <a:latin typeface="Segoe UI"/>
+              </a:rPr>
+              <a:t>NO KEYS, NO GITHUB SECRETS — THIS STRING IS THE ENTIRE CREDENTIAL</a:t>
+            </a:r>
+          </a:p>
           <a:p>
             <a:pPr algn="l">
               <a:spcAft>
@@ -3675,6 +3737,45 @@
               </a:spcAft>
             </a:pPr>
             <a:r>
+              <a:rPr sz="1250" b="1">
+                <a:solidFill>
+                  <a:srgbClr val="1F1235"/>
+                </a:solidFill>
+                <a:latin typeface="Consolas"/>
+              </a:rPr>
+              <a:t>sub = repo:ClintPollock/britive-jit-demo:ref:refs/heads/main</a:t>
+            </a:r>
+          </a:p>
+        </p:txBody>
+      </p:sp>
+      <p:sp>
+        <p:nvSpPr>
+          <p:cNvPr id="13" name="TextBox 12"/>
+          <p:cNvSpPr txBox="1"/>
+          <p:nvPr/>
+        </p:nvSpPr>
+        <p:spPr>
+          <a:xfrm>
+            <a:off x="640080" y="3529584"/>
+            <a:ext cx="10972800" cy="274320"/>
+          </a:xfrm>
+          <a:prstGeom prst="rect">
+            <a:avLst/>
+          </a:prstGeom>
+          <a:noFill/>
+        </p:spPr>
+        <p:txBody>
+          <a:bodyPr wrap="square" anchor="t" lIns="0" rIns="0" tIns="0" bIns="0">
+            <a:spAutoFit/>
+          </a:bodyPr>
+          <a:lstStyle/>
+          <a:p>
+            <a:pPr algn="l">
+              <a:spcAft>
+                <a:spcPts val="0"/>
+              </a:spcAft>
+            </a:pPr>
+            <a:r>
               <a:rPr sz="1000" b="1">
                 <a:solidFill>
                   <a:srgbClr val="6C4BB6"/>
@@ -3688,14 +3789,14 @@
       </p:sp>
       <p:sp>
         <p:nvSpPr>
-          <p:cNvPr id="12" name="Rounded Rectangle 11"/>
+          <p:cNvPr id="14" name="Rounded Rectangle 13"/>
           <p:cNvSpPr/>
           <p:nvPr/>
         </p:nvSpPr>
         <p:spPr>
           <a:xfrm>
-            <a:off x="640080" y="3310128"/>
-            <a:ext cx="10927080" cy="2103120"/>
+            <a:off x="640080" y="3803904"/>
+            <a:ext cx="10927080" cy="1993392"/>
           </a:xfrm>
           <a:prstGeom prst="roundRect">
             <a:avLst>
@@ -3734,14 +3835,14 @@
       </p:sp>
       <p:sp>
         <p:nvSpPr>
-          <p:cNvPr id="13" name="TextBox 12"/>
+          <p:cNvPr id="15" name="TextBox 14"/>
           <p:cNvSpPr txBox="1"/>
           <p:nvPr/>
         </p:nvSpPr>
         <p:spPr>
           <a:xfrm>
-            <a:off x="960120" y="3493008"/>
-            <a:ext cx="10332720" cy="1828800"/>
+            <a:off x="960120" y="3950208"/>
+            <a:ext cx="10332720" cy="1737360"/>
           </a:xfrm>
           <a:prstGeom prst="rect">
             <a:avLst/>
@@ -3853,13 +3954,13 @@
       </p:sp>
       <p:sp>
         <p:nvSpPr>
-          <p:cNvPr id="14" name="TextBox 13"/>
+          <p:cNvPr id="16" name="TextBox 15"/>
           <p:cNvSpPr txBox="1"/>
           <p:nvPr/>
         </p:nvSpPr>
         <p:spPr>
           <a:xfrm>
-            <a:off x="640080" y="5650992"/>
+            <a:off x="640080" y="6016752"/>
             <a:ext cx="10972800" cy="365760"/>
           </a:xfrm>
           <a:prstGeom prst="rect">

</xml_diff>